<commit_message>
manuscript minor revisions updates
</commit_message>
<xml_diff>
--- a/tables_figures/final-tables_figures/conceptual_diagram.pptx
+++ b/tables_figures/final-tables_figures/conceptual_diagram.pptx
@@ -109,6 +109,11 @@
       </a:defRPr>
     </a:lvl9pPr>
   </p:defaultTextStyle>
+  <p:extLst>
+    <p:ext uri="{EFAFB233-063F-42B5-8137-9DF3F51BA10A}">
+      <p15:sldGuideLst xmlns:p15="http://schemas.microsoft.com/office/powerpoint/2012/main"/>
+    </p:ext>
+  </p:extLst>
 </p:presentation>
 </file>
 
@@ -121,7 +126,7 @@
 <file path=ppt/revisionInfo.xml><?xml version="1.0" encoding="utf-8"?>
 <p1510:revInfo xmlns:a="http://schemas.openxmlformats.org/drawingml/2006/main" xmlns:r="http://schemas.openxmlformats.org/officeDocument/2006/relationships" xmlns:p1510="http://schemas.microsoft.com/office/powerpoint/2015/10/main">
   <p1510:revLst>
-    <p1510:client id="{E1E50520-6CAF-470A-84EB-2E8DC844BFE7}" v="67" dt="2025-12-16T14:43:07.932"/>
+    <p1510:client id="{D01FE5BD-F5C4-4027-B437-BA909DD6650F}" v="3" dt="2026-03-14T23:46:40.290"/>
   </p1510:revLst>
 </p1510:revInfo>
 </file>
@@ -129,642 +134,40 @@
 <file path=ppt/changesInfos/changesInfo1.xml><?xml version="1.0" encoding="utf-8"?>
 <pc:chgInfo xmlns:a="http://schemas.openxmlformats.org/drawingml/2006/main" xmlns:r="http://schemas.openxmlformats.org/officeDocument/2006/relationships" xmlns:ac="http://schemas.microsoft.com/office/drawing/2013/main/command" xmlns:pc="http://schemas.microsoft.com/office/powerpoint/2013/main/command">
   <pc:docChgLst>
-    <pc:chgData name="Sandra Klemet-N'guessan" userId="0d19dd2d-6e00-409e-9933-e191f280205d" providerId="ADAL" clId="{CE03E1C6-2D51-4ED0-B122-F20503508803}"/>
-    <pc:docChg chg="undo redo custSel addSld delSld modSld">
-      <pc:chgData name="Sandra Klemet-N'guessan" userId="0d19dd2d-6e00-409e-9933-e191f280205d" providerId="ADAL" clId="{CE03E1C6-2D51-4ED0-B122-F20503508803}" dt="2025-12-16T14:45:46.099" v="630" actId="1076"/>
+    <pc:chgData name="Sandra Klemet-N'guessan" userId="0d19dd2d-6e00-409e-9933-e191f280205d" providerId="ADAL" clId="{89BD5EB5-483A-4D23-98EB-6C08039E7710}"/>
+    <pc:docChg chg="modSld">
+      <pc:chgData name="Sandra Klemet-N'guessan" userId="0d19dd2d-6e00-409e-9933-e191f280205d" providerId="ADAL" clId="{89BD5EB5-483A-4D23-98EB-6C08039E7710}" dt="2026-03-14T23:49:05.140" v="27" actId="167"/>
       <pc:docMkLst>
         <pc:docMk/>
       </pc:docMkLst>
-      <pc:sldChg chg="addSp delSp modSp mod modCm modNotesTx">
-        <pc:chgData name="Sandra Klemet-N'guessan" userId="0d19dd2d-6e00-409e-9933-e191f280205d" providerId="ADAL" clId="{CE03E1C6-2D51-4ED0-B122-F20503508803}" dt="2025-12-16T10:52:29.387" v="434" actId="14100"/>
-        <pc:sldMkLst>
-          <pc:docMk/>
-          <pc:sldMk cId="861659189" sldId="258"/>
-        </pc:sldMkLst>
-        <pc:spChg chg="mod">
-          <ac:chgData name="Sandra Klemet-N'guessan" userId="0d19dd2d-6e00-409e-9933-e191f280205d" providerId="ADAL" clId="{CE03E1C6-2D51-4ED0-B122-F20503508803}" dt="2025-12-16T09:58:19.237" v="43" actId="14100"/>
-          <ac:spMkLst>
-            <pc:docMk/>
-            <pc:sldMk cId="861659189" sldId="258"/>
-            <ac:spMk id="2" creationId="{35E397F4-F1FE-8F5D-8D52-1636AD8A4F81}"/>
-          </ac:spMkLst>
-        </pc:spChg>
-        <pc:spChg chg="mod">
-          <ac:chgData name="Sandra Klemet-N'guessan" userId="0d19dd2d-6e00-409e-9933-e191f280205d" providerId="ADAL" clId="{CE03E1C6-2D51-4ED0-B122-F20503508803}" dt="2025-12-16T10:23:18.420" v="218" actId="20577"/>
-          <ac:spMkLst>
-            <pc:docMk/>
-            <pc:sldMk cId="861659189" sldId="258"/>
-            <ac:spMk id="3" creationId="{B5F3289C-90D8-354D-7392-F0DCC6D16809}"/>
-          </ac:spMkLst>
-        </pc:spChg>
-        <pc:spChg chg="mod">
-          <ac:chgData name="Sandra Klemet-N'guessan" userId="0d19dd2d-6e00-409e-9933-e191f280205d" providerId="ADAL" clId="{CE03E1C6-2D51-4ED0-B122-F20503508803}" dt="2025-12-16T10:05:22.419" v="95" actId="1076"/>
-          <ac:spMkLst>
-            <pc:docMk/>
-            <pc:sldMk cId="861659189" sldId="258"/>
-            <ac:spMk id="10" creationId="{011FB80E-45E7-82EF-E95A-2D8696B6E968}"/>
-          </ac:spMkLst>
-        </pc:spChg>
-        <pc:spChg chg="mod">
-          <ac:chgData name="Sandra Klemet-N'guessan" userId="0d19dd2d-6e00-409e-9933-e191f280205d" providerId="ADAL" clId="{CE03E1C6-2D51-4ED0-B122-F20503508803}" dt="2025-12-16T10:05:22.419" v="95" actId="1076"/>
-          <ac:spMkLst>
-            <pc:docMk/>
-            <pc:sldMk cId="861659189" sldId="258"/>
-            <ac:spMk id="11" creationId="{E0786068-976E-A670-4799-3C3EAB5E2140}"/>
-          </ac:spMkLst>
-        </pc:spChg>
-        <pc:spChg chg="mod">
-          <ac:chgData name="Sandra Klemet-N'guessan" userId="0d19dd2d-6e00-409e-9933-e191f280205d" providerId="ADAL" clId="{CE03E1C6-2D51-4ED0-B122-F20503508803}" dt="2025-12-16T10:41:11.013" v="372" actId="1076"/>
-          <ac:spMkLst>
-            <pc:docMk/>
-            <pc:sldMk cId="861659189" sldId="258"/>
-            <ac:spMk id="12" creationId="{453EE493-DD90-4C11-998C-BEFB4E932E8A}"/>
-          </ac:spMkLst>
-        </pc:spChg>
-        <pc:spChg chg="mod">
-          <ac:chgData name="Sandra Klemet-N'guessan" userId="0d19dd2d-6e00-409e-9933-e191f280205d" providerId="ADAL" clId="{CE03E1C6-2D51-4ED0-B122-F20503508803}" dt="2025-12-16T10:06:22.079" v="98" actId="1076"/>
-          <ac:spMkLst>
-            <pc:docMk/>
-            <pc:sldMk cId="861659189" sldId="258"/>
-            <ac:spMk id="13" creationId="{466A50A4-39FE-35CF-DECE-DEFEBA9DDB45}"/>
-          </ac:spMkLst>
-        </pc:spChg>
-        <pc:spChg chg="mod">
-          <ac:chgData name="Sandra Klemet-N'guessan" userId="0d19dd2d-6e00-409e-9933-e191f280205d" providerId="ADAL" clId="{CE03E1C6-2D51-4ED0-B122-F20503508803}" dt="2025-12-16T10:41:02.720" v="370" actId="1076"/>
-          <ac:spMkLst>
-            <pc:docMk/>
-            <pc:sldMk cId="861659189" sldId="258"/>
-            <ac:spMk id="15" creationId="{7228453D-1115-C2EC-1F37-367198C8CD12}"/>
-          </ac:spMkLst>
-        </pc:spChg>
-        <pc:spChg chg="del">
-          <ac:chgData name="Sandra Klemet-N'guessan" userId="0d19dd2d-6e00-409e-9933-e191f280205d" providerId="ADAL" clId="{CE03E1C6-2D51-4ED0-B122-F20503508803}" dt="2025-12-16T09:53:42.920" v="0" actId="478"/>
-          <ac:spMkLst>
-            <pc:docMk/>
-            <pc:sldMk cId="861659189" sldId="258"/>
-            <ac:spMk id="16" creationId="{8E05E7B8-9965-8FBD-8992-38D9EDB3CC73}"/>
-          </ac:spMkLst>
-        </pc:spChg>
-        <pc:spChg chg="mod">
-          <ac:chgData name="Sandra Klemet-N'guessan" userId="0d19dd2d-6e00-409e-9933-e191f280205d" providerId="ADAL" clId="{CE03E1C6-2D51-4ED0-B122-F20503508803}" dt="2025-12-16T10:20:00.579" v="170" actId="1076"/>
-          <ac:spMkLst>
-            <pc:docMk/>
-            <pc:sldMk cId="861659189" sldId="258"/>
-            <ac:spMk id="17" creationId="{E5340DD9-52EB-E7FB-80A0-769E1DB5E7D6}"/>
-          </ac:spMkLst>
-        </pc:spChg>
-        <pc:spChg chg="mod">
-          <ac:chgData name="Sandra Klemet-N'guessan" userId="0d19dd2d-6e00-409e-9933-e191f280205d" providerId="ADAL" clId="{CE03E1C6-2D51-4ED0-B122-F20503508803}" dt="2025-12-16T10:06:12.014" v="97" actId="1076"/>
-          <ac:spMkLst>
-            <pc:docMk/>
-            <pc:sldMk cId="861659189" sldId="258"/>
-            <ac:spMk id="19" creationId="{77D5AE27-B84C-2864-B30D-4357A95CC969}"/>
-          </ac:spMkLst>
-        </pc:spChg>
-        <pc:spChg chg="mod">
-          <ac:chgData name="Sandra Klemet-N'guessan" userId="0d19dd2d-6e00-409e-9933-e191f280205d" providerId="ADAL" clId="{CE03E1C6-2D51-4ED0-B122-F20503508803}" dt="2025-12-16T10:07:43.678" v="109" actId="1076"/>
-          <ac:spMkLst>
-            <pc:docMk/>
-            <pc:sldMk cId="861659189" sldId="258"/>
-            <ac:spMk id="20" creationId="{D06366CD-A67C-6ADB-9701-AC58C6EF35B2}"/>
-          </ac:spMkLst>
-        </pc:spChg>
-        <pc:spChg chg="mod">
-          <ac:chgData name="Sandra Klemet-N'guessan" userId="0d19dd2d-6e00-409e-9933-e191f280205d" providerId="ADAL" clId="{CE03E1C6-2D51-4ED0-B122-F20503508803}" dt="2025-12-16T10:51:40.175" v="427" actId="1076"/>
-          <ac:spMkLst>
-            <pc:docMk/>
-            <pc:sldMk cId="861659189" sldId="258"/>
-            <ac:spMk id="21" creationId="{33DEC2B4-3762-6B80-BD4D-C1F147698386}"/>
-          </ac:spMkLst>
-        </pc:spChg>
-        <pc:spChg chg="mod">
-          <ac:chgData name="Sandra Klemet-N'guessan" userId="0d19dd2d-6e00-409e-9933-e191f280205d" providerId="ADAL" clId="{CE03E1C6-2D51-4ED0-B122-F20503508803}" dt="2025-12-16T10:16:19.248" v="162" actId="14100"/>
-          <ac:spMkLst>
-            <pc:docMk/>
-            <pc:sldMk cId="861659189" sldId="258"/>
-            <ac:spMk id="28" creationId="{72EEB488-1087-AFA3-1F05-5D1AA66B2F1C}"/>
-          </ac:spMkLst>
-        </pc:spChg>
-        <pc:spChg chg="del">
-          <ac:chgData name="Sandra Klemet-N'guessan" userId="0d19dd2d-6e00-409e-9933-e191f280205d" providerId="ADAL" clId="{CE03E1C6-2D51-4ED0-B122-F20503508803}" dt="2025-12-16T09:54:37.300" v="9" actId="478"/>
-          <ac:spMkLst>
-            <pc:docMk/>
-            <pc:sldMk cId="861659189" sldId="258"/>
-            <ac:spMk id="35" creationId="{7676B252-4200-8047-1C14-3A9350AF4A25}"/>
-          </ac:spMkLst>
-        </pc:spChg>
-        <pc:spChg chg="del">
-          <ac:chgData name="Sandra Klemet-N'guessan" userId="0d19dd2d-6e00-409e-9933-e191f280205d" providerId="ADAL" clId="{CE03E1C6-2D51-4ED0-B122-F20503508803}" dt="2025-12-16T09:54:38.110" v="10" actId="478"/>
-          <ac:spMkLst>
-            <pc:docMk/>
-            <pc:sldMk cId="861659189" sldId="258"/>
-            <ac:spMk id="36" creationId="{5B625E35-6A4B-E2F7-F2C8-4FBD737E9D35}"/>
-          </ac:spMkLst>
-        </pc:spChg>
-        <pc:spChg chg="mod">
-          <ac:chgData name="Sandra Klemet-N'guessan" userId="0d19dd2d-6e00-409e-9933-e191f280205d" providerId="ADAL" clId="{CE03E1C6-2D51-4ED0-B122-F20503508803}" dt="2025-12-16T10:12:02.060" v="131" actId="1076"/>
-          <ac:spMkLst>
-            <pc:docMk/>
-            <pc:sldMk cId="861659189" sldId="258"/>
-            <ac:spMk id="37" creationId="{471005D6-648B-9BD1-AB78-2F342B3334F0}"/>
-          </ac:spMkLst>
-        </pc:spChg>
-        <pc:spChg chg="mod">
-          <ac:chgData name="Sandra Klemet-N'guessan" userId="0d19dd2d-6e00-409e-9933-e191f280205d" providerId="ADAL" clId="{CE03E1C6-2D51-4ED0-B122-F20503508803}" dt="2025-12-16T10:15:51.330" v="159" actId="1076"/>
-          <ac:spMkLst>
-            <pc:docMk/>
-            <pc:sldMk cId="861659189" sldId="258"/>
-            <ac:spMk id="42" creationId="{130C9660-BEFE-523C-3DF8-3EABE72E2C15}"/>
-          </ac:spMkLst>
-        </pc:spChg>
-        <pc:spChg chg="mod">
-          <ac:chgData name="Sandra Klemet-N'guessan" userId="0d19dd2d-6e00-409e-9933-e191f280205d" providerId="ADAL" clId="{CE03E1C6-2D51-4ED0-B122-F20503508803}" dt="2025-12-16T10:51:30.859" v="426" actId="1076"/>
-          <ac:spMkLst>
-            <pc:docMk/>
-            <pc:sldMk cId="861659189" sldId="258"/>
-            <ac:spMk id="52" creationId="{380777CF-4004-C168-94AB-13E879B0BA54}"/>
-          </ac:spMkLst>
-        </pc:spChg>
-        <pc:spChg chg="add mod">
-          <ac:chgData name="Sandra Klemet-N'guessan" userId="0d19dd2d-6e00-409e-9933-e191f280205d" providerId="ADAL" clId="{CE03E1C6-2D51-4ED0-B122-F20503508803}" dt="2025-12-16T10:50:46.721" v="417" actId="208"/>
-          <ac:spMkLst>
-            <pc:docMk/>
-            <pc:sldMk cId="861659189" sldId="258"/>
-            <ac:spMk id="57" creationId="{6722105A-A4D6-C67D-6E86-1A8CE83561C0}"/>
-          </ac:spMkLst>
-        </pc:spChg>
-        <pc:spChg chg="add mod">
-          <ac:chgData name="Sandra Klemet-N'guessan" userId="0d19dd2d-6e00-409e-9933-e191f280205d" providerId="ADAL" clId="{CE03E1C6-2D51-4ED0-B122-F20503508803}" dt="2025-12-16T10:50:44.722" v="416" actId="208"/>
-          <ac:spMkLst>
-            <pc:docMk/>
-            <pc:sldMk cId="861659189" sldId="258"/>
-            <ac:spMk id="58" creationId="{43B3B498-20DD-68A2-00BE-D80F8D114296}"/>
-          </ac:spMkLst>
-        </pc:spChg>
-        <pc:spChg chg="add mod">
-          <ac:chgData name="Sandra Klemet-N'guessan" userId="0d19dd2d-6e00-409e-9933-e191f280205d" providerId="ADAL" clId="{CE03E1C6-2D51-4ED0-B122-F20503508803}" dt="2025-12-16T10:50:48.356" v="418" actId="208"/>
-          <ac:spMkLst>
-            <pc:docMk/>
-            <pc:sldMk cId="861659189" sldId="258"/>
-            <ac:spMk id="59" creationId="{E6E7798F-1E9A-2322-13CE-A7EA1F64F423}"/>
-          </ac:spMkLst>
-        </pc:spChg>
-        <pc:spChg chg="add mod">
-          <ac:chgData name="Sandra Klemet-N'guessan" userId="0d19dd2d-6e00-409e-9933-e191f280205d" providerId="ADAL" clId="{CE03E1C6-2D51-4ED0-B122-F20503508803}" dt="2025-12-16T10:30:03.707" v="279" actId="20577"/>
-          <ac:spMkLst>
-            <pc:docMk/>
-            <pc:sldMk cId="861659189" sldId="258"/>
-            <ac:spMk id="72" creationId="{3009B1C6-B337-CE5F-C3CF-AB87D0BB4D3F}"/>
-          </ac:spMkLst>
-        </pc:spChg>
-        <pc:spChg chg="add">
-          <ac:chgData name="Sandra Klemet-N'guessan" userId="0d19dd2d-6e00-409e-9933-e191f280205d" providerId="ADAL" clId="{CE03E1C6-2D51-4ED0-B122-F20503508803}" dt="2025-12-16T10:46:29.570" v="376"/>
-          <ac:spMkLst>
-            <pc:docMk/>
-            <pc:sldMk cId="861659189" sldId="258"/>
-            <ac:spMk id="97" creationId="{756689F5-8503-E925-131B-FE126CFE3528}"/>
-          </ac:spMkLst>
-        </pc:spChg>
-        <pc:spChg chg="add">
-          <ac:chgData name="Sandra Klemet-N'guessan" userId="0d19dd2d-6e00-409e-9933-e191f280205d" providerId="ADAL" clId="{CE03E1C6-2D51-4ED0-B122-F20503508803}" dt="2025-12-16T10:47:47.204" v="393"/>
-          <ac:spMkLst>
-            <pc:docMk/>
-            <pc:sldMk cId="861659189" sldId="258"/>
-            <ac:spMk id="99" creationId="{31F844C1-FF9A-4D7C-2E06-CBBAAEAC4944}"/>
-          </ac:spMkLst>
-        </pc:spChg>
-        <pc:spChg chg="add mod">
-          <ac:chgData name="Sandra Klemet-N'guessan" userId="0d19dd2d-6e00-409e-9933-e191f280205d" providerId="ADAL" clId="{CE03E1C6-2D51-4ED0-B122-F20503508803}" dt="2025-12-16T10:47:51.545" v="396"/>
-          <ac:spMkLst>
-            <pc:docMk/>
-            <pc:sldMk cId="861659189" sldId="258"/>
-            <ac:spMk id="100" creationId="{7B372C61-0954-C374-1434-7DEF3811151A}"/>
-          </ac:spMkLst>
-        </pc:spChg>
-        <pc:picChg chg="add del mod">
-          <ac:chgData name="Sandra Klemet-N'guessan" userId="0d19dd2d-6e00-409e-9933-e191f280205d" providerId="ADAL" clId="{CE03E1C6-2D51-4ED0-B122-F20503508803}" dt="2025-12-16T10:40:27.094" v="366" actId="478"/>
-          <ac:picMkLst>
-            <pc:docMk/>
-            <pc:sldMk cId="861659189" sldId="258"/>
-            <ac:picMk id="96" creationId="{A8C9E4FC-B301-3372-28C8-01C6B9B189D5}"/>
-          </ac:picMkLst>
-        </pc:picChg>
-        <pc:picChg chg="add del mod">
-          <ac:chgData name="Sandra Klemet-N'guessan" userId="0d19dd2d-6e00-409e-9933-e191f280205d" providerId="ADAL" clId="{CE03E1C6-2D51-4ED0-B122-F20503508803}" dt="2025-12-16T10:46:46.558" v="380" actId="478"/>
-          <ac:picMkLst>
-            <pc:docMk/>
-            <pc:sldMk cId="861659189" sldId="258"/>
-            <ac:picMk id="98" creationId="{81F1DEF0-F035-E1E6-570A-2B668868F3DC}"/>
-          </ac:picMkLst>
-        </pc:picChg>
-        <pc:picChg chg="add del mod">
-          <ac:chgData name="Sandra Klemet-N'guessan" userId="0d19dd2d-6e00-409e-9933-e191f280205d" providerId="ADAL" clId="{CE03E1C6-2D51-4ED0-B122-F20503508803}" dt="2025-12-16T10:48:09.478" v="402" actId="478"/>
-          <ac:picMkLst>
-            <pc:docMk/>
-            <pc:sldMk cId="861659189" sldId="258"/>
-            <ac:picMk id="101" creationId="{20B7EBC4-01E5-8D9A-4FD1-F538F83533E2}"/>
-          </ac:picMkLst>
-        </pc:picChg>
-        <pc:cxnChg chg="mod">
-          <ac:chgData name="Sandra Klemet-N'guessan" userId="0d19dd2d-6e00-409e-9933-e191f280205d" providerId="ADAL" clId="{CE03E1C6-2D51-4ED0-B122-F20503508803}" dt="2025-12-16T10:51:00.764" v="422" actId="208"/>
-          <ac:cxnSpMkLst>
-            <pc:docMk/>
-            <pc:sldMk cId="861659189" sldId="258"/>
-            <ac:cxnSpMk id="5" creationId="{EB0BFD4E-403F-F961-2E74-37693228D8AE}"/>
-          </ac:cxnSpMkLst>
-        </pc:cxnChg>
-        <pc:cxnChg chg="mod">
-          <ac:chgData name="Sandra Klemet-N'guessan" userId="0d19dd2d-6e00-409e-9933-e191f280205d" providerId="ADAL" clId="{CE03E1C6-2D51-4ED0-B122-F20503508803}" dt="2025-12-16T10:50:52.359" v="420" actId="208"/>
-          <ac:cxnSpMkLst>
-            <pc:docMk/>
-            <pc:sldMk cId="861659189" sldId="258"/>
-            <ac:cxnSpMk id="8" creationId="{067D76DE-CEE1-C8A8-7FC5-AAC484AECC83}"/>
-          </ac:cxnSpMkLst>
-        </pc:cxnChg>
-        <pc:cxnChg chg="mod">
-          <ac:chgData name="Sandra Klemet-N'guessan" userId="0d19dd2d-6e00-409e-9933-e191f280205d" providerId="ADAL" clId="{CE03E1C6-2D51-4ED0-B122-F20503508803}" dt="2025-12-16T10:50:50.345" v="419" actId="208"/>
-          <ac:cxnSpMkLst>
-            <pc:docMk/>
-            <pc:sldMk cId="861659189" sldId="258"/>
-            <ac:cxnSpMk id="14" creationId="{0BED4DC9-3CF1-8A46-09CE-435BB45ED78C}"/>
-          </ac:cxnSpMkLst>
-        </pc:cxnChg>
-        <pc:cxnChg chg="mod">
-          <ac:chgData name="Sandra Klemet-N'guessan" userId="0d19dd2d-6e00-409e-9933-e191f280205d" providerId="ADAL" clId="{CE03E1C6-2D51-4ED0-B122-F20503508803}" dt="2025-12-16T10:51:50.391" v="428" actId="1076"/>
-          <ac:cxnSpMkLst>
-            <pc:docMk/>
-            <pc:sldMk cId="861659189" sldId="258"/>
-            <ac:cxnSpMk id="22" creationId="{13C0CC88-FF36-2D6D-716E-2ED6164AE95E}"/>
-          </ac:cxnSpMkLst>
-        </pc:cxnChg>
-        <pc:cxnChg chg="mod">
-          <ac:chgData name="Sandra Klemet-N'guessan" userId="0d19dd2d-6e00-409e-9933-e191f280205d" providerId="ADAL" clId="{CE03E1C6-2D51-4ED0-B122-F20503508803}" dt="2025-12-16T10:50:58.392" v="421" actId="208"/>
-          <ac:cxnSpMkLst>
-            <pc:docMk/>
-            <pc:sldMk cId="861659189" sldId="258"/>
-            <ac:cxnSpMk id="27" creationId="{DDA6C313-22D1-B4CC-1B93-5F587E7E271C}"/>
-          </ac:cxnSpMkLst>
-        </pc:cxnChg>
-        <pc:cxnChg chg="mod">
-          <ac:chgData name="Sandra Klemet-N'guessan" userId="0d19dd2d-6e00-409e-9933-e191f280205d" providerId="ADAL" clId="{CE03E1C6-2D51-4ED0-B122-F20503508803}" dt="2025-12-16T10:51:02.728" v="423" actId="208"/>
-          <ac:cxnSpMkLst>
-            <pc:docMk/>
-            <pc:sldMk cId="861659189" sldId="258"/>
-            <ac:cxnSpMk id="33" creationId="{1B6EB629-3045-F4D0-50A7-897E62791C8F}"/>
-          </ac:cxnSpMkLst>
-        </pc:cxnChg>
-        <pc:cxnChg chg="mod">
-          <ac:chgData name="Sandra Klemet-N'guessan" userId="0d19dd2d-6e00-409e-9933-e191f280205d" providerId="ADAL" clId="{CE03E1C6-2D51-4ED0-B122-F20503508803}" dt="2025-12-16T10:52:19.571" v="433" actId="14100"/>
-          <ac:cxnSpMkLst>
-            <pc:docMk/>
-            <pc:sldMk cId="861659189" sldId="258"/>
-            <ac:cxnSpMk id="38" creationId="{97497D67-1353-5C22-4C08-3EE30A4B10F7}"/>
-          </ac:cxnSpMkLst>
-        </pc:cxnChg>
-        <pc:cxnChg chg="mod">
-          <ac:chgData name="Sandra Klemet-N'guessan" userId="0d19dd2d-6e00-409e-9933-e191f280205d" providerId="ADAL" clId="{CE03E1C6-2D51-4ED0-B122-F20503508803}" dt="2025-12-16T10:51:11.501" v="425" actId="208"/>
-          <ac:cxnSpMkLst>
-            <pc:docMk/>
-            <pc:sldMk cId="861659189" sldId="258"/>
-            <ac:cxnSpMk id="41" creationId="{D59D5E27-2C96-1C95-6854-9F7F7F989C3F}"/>
-          </ac:cxnSpMkLst>
-        </pc:cxnChg>
-        <pc:cxnChg chg="mod">
-          <ac:chgData name="Sandra Klemet-N'guessan" userId="0d19dd2d-6e00-409e-9933-e191f280205d" providerId="ADAL" clId="{CE03E1C6-2D51-4ED0-B122-F20503508803}" dt="2025-12-16T10:52:29.387" v="434" actId="14100"/>
-          <ac:cxnSpMkLst>
-            <pc:docMk/>
-            <pc:sldMk cId="861659189" sldId="258"/>
-            <ac:cxnSpMk id="46" creationId="{BA7B418D-AB4B-F752-7E3F-E287490ABFE9}"/>
-          </ac:cxnSpMkLst>
-        </pc:cxnChg>
-        <pc:cxnChg chg="mod">
-          <ac:chgData name="Sandra Klemet-N'guessan" userId="0d19dd2d-6e00-409e-9933-e191f280205d" providerId="ADAL" clId="{CE03E1C6-2D51-4ED0-B122-F20503508803}" dt="2025-12-16T10:52:16.481" v="432" actId="14100"/>
-          <ac:cxnSpMkLst>
-            <pc:docMk/>
-            <pc:sldMk cId="861659189" sldId="258"/>
-            <ac:cxnSpMk id="48" creationId="{8B19A7AB-3EE6-7908-1967-62949B70D293}"/>
-          </ac:cxnSpMkLst>
-        </pc:cxnChg>
-        <pc:extLst>
-          <p:ext xmlns:p="http://schemas.openxmlformats.org/presentationml/2006/main" uri="{D6D511B9-2390-475A-947B-AFAB55BFBCF1}">
-            <pc226:cmChg xmlns:pc226="http://schemas.microsoft.com/office/powerpoint/2022/06/main/command" chg="mod">
-              <pc226:chgData name="Sandra Klemet-N'guessan" userId="0d19dd2d-6e00-409e-9933-e191f280205d" providerId="ADAL" clId="{CE03E1C6-2D51-4ED0-B122-F20503508803}" dt="2025-12-16T10:23:18.420" v="218" actId="20577"/>
-              <pc2:cmMkLst xmlns:pc2="http://schemas.microsoft.com/office/powerpoint/2019/9/main/command">
-                <pc:docMk/>
-                <pc:sldMk cId="861659189" sldId="258"/>
-                <pc2:cmMk id="{39EA9851-B82F-439A-9494-B3917ACEA77F}"/>
-              </pc2:cmMkLst>
-            </pc226:cmChg>
-          </p:ext>
-        </pc:extLst>
-      </pc:sldChg>
-      <pc:sldChg chg="addSp delSp modSp new del mod">
-        <pc:chgData name="Sandra Klemet-N'guessan" userId="0d19dd2d-6e00-409e-9933-e191f280205d" providerId="ADAL" clId="{CE03E1C6-2D51-4ED0-B122-F20503508803}" dt="2025-12-16T10:52:46.466" v="436" actId="47"/>
-        <pc:sldMkLst>
-          <pc:docMk/>
-          <pc:sldMk cId="3568673982" sldId="259"/>
-        </pc:sldMkLst>
-        <pc:picChg chg="add del mod">
-          <ac:chgData name="Sandra Klemet-N'guessan" userId="0d19dd2d-6e00-409e-9933-e191f280205d" providerId="ADAL" clId="{CE03E1C6-2D51-4ED0-B122-F20503508803}" dt="2025-12-16T10:39:52.600" v="361" actId="478"/>
-          <ac:picMkLst>
-            <pc:docMk/>
-            <pc:sldMk cId="3568673982" sldId="259"/>
-            <ac:picMk id="3" creationId="{9F11D48E-255E-1D3B-4F6C-4FEA0D7A70E3}"/>
-          </ac:picMkLst>
-        </pc:picChg>
-      </pc:sldChg>
-      <pc:sldChg chg="addSp delSp modSp add mod modAnim modNotesTx">
-        <pc:chgData name="Sandra Klemet-N'guessan" userId="0d19dd2d-6e00-409e-9933-e191f280205d" providerId="ADAL" clId="{CE03E1C6-2D51-4ED0-B122-F20503508803}" dt="2025-12-16T14:45:46.099" v="630" actId="1076"/>
+      <pc:sldChg chg="addSp modSp mod">
+        <pc:chgData name="Sandra Klemet-N'guessan" userId="0d19dd2d-6e00-409e-9933-e191f280205d" providerId="ADAL" clId="{89BD5EB5-483A-4D23-98EB-6C08039E7710}" dt="2026-03-14T23:49:05.140" v="27" actId="167"/>
         <pc:sldMkLst>
           <pc:docMk/>
           <pc:sldMk cId="2622637710" sldId="260"/>
         </pc:sldMkLst>
-        <pc:spChg chg="mod">
-          <ac:chgData name="Sandra Klemet-N'guessan" userId="0d19dd2d-6e00-409e-9933-e191f280205d" providerId="ADAL" clId="{CE03E1C6-2D51-4ED0-B122-F20503508803}" dt="2025-12-16T14:45:46.099" v="630" actId="1076"/>
+        <pc:spChg chg="add mod">
+          <ac:chgData name="Sandra Klemet-N'guessan" userId="0d19dd2d-6e00-409e-9933-e191f280205d" providerId="ADAL" clId="{89BD5EB5-483A-4D23-98EB-6C08039E7710}" dt="2026-03-14T23:47:53.480" v="16" actId="1076"/>
           <ac:spMkLst>
             <pc:docMk/>
             <pc:sldMk cId="2622637710" sldId="260"/>
-            <ac:spMk id="3" creationId="{0656ED09-B86F-DC05-950C-C108AA23434C}"/>
+            <ac:spMk id="13" creationId="{EC325244-F071-15DE-8442-D93324BA0D3C}"/>
           </ac:spMkLst>
         </pc:spChg>
         <pc:spChg chg="mod">
-          <ac:chgData name="Sandra Klemet-N'guessan" userId="0d19dd2d-6e00-409e-9933-e191f280205d" providerId="ADAL" clId="{CE03E1C6-2D51-4ED0-B122-F20503508803}" dt="2025-12-16T14:25:28.234" v="590" actId="20577"/>
-          <ac:spMkLst>
-            <pc:docMk/>
-            <pc:sldMk cId="2622637710" sldId="260"/>
-            <ac:spMk id="4" creationId="{7FD27F93-AFDF-8121-F11A-A3CA749CAB89}"/>
-          </ac:spMkLst>
-        </pc:spChg>
-        <pc:spChg chg="mod">
-          <ac:chgData name="Sandra Klemet-N'guessan" userId="0d19dd2d-6e00-409e-9933-e191f280205d" providerId="ADAL" clId="{CE03E1C6-2D51-4ED0-B122-F20503508803}" dt="2025-12-16T14:45:06.781" v="624" actId="1076"/>
-          <ac:spMkLst>
-            <pc:docMk/>
-            <pc:sldMk cId="2622637710" sldId="260"/>
-            <ac:spMk id="10" creationId="{27AA275E-7548-40EC-F343-BB463A922952}"/>
-          </ac:spMkLst>
-        </pc:spChg>
-        <pc:spChg chg="del">
-          <ac:chgData name="Sandra Klemet-N'guessan" userId="0d19dd2d-6e00-409e-9933-e191f280205d" providerId="ADAL" clId="{CE03E1C6-2D51-4ED0-B122-F20503508803}" dt="2025-12-16T10:52:50.586" v="437" actId="478"/>
-          <ac:spMkLst>
-            <pc:docMk/>
-            <pc:sldMk cId="2622637710" sldId="260"/>
-            <ac:spMk id="11" creationId="{7C4D5488-7919-E0C0-C89B-865C8ABBD282}"/>
-          </ac:spMkLst>
-        </pc:spChg>
-        <pc:spChg chg="mod">
-          <ac:chgData name="Sandra Klemet-N'guessan" userId="0d19dd2d-6e00-409e-9933-e191f280205d" providerId="ADAL" clId="{CE03E1C6-2D51-4ED0-B122-F20503508803}" dt="2025-12-16T14:43:07.932" v="602" actId="1076"/>
-          <ac:spMkLst>
-            <pc:docMk/>
-            <pc:sldMk cId="2622637710" sldId="260"/>
-            <ac:spMk id="12" creationId="{D59E2F3D-5711-D809-DE65-FC25B6935C2F}"/>
-          </ac:spMkLst>
-        </pc:spChg>
-        <pc:spChg chg="del">
-          <ac:chgData name="Sandra Klemet-N'guessan" userId="0d19dd2d-6e00-409e-9933-e191f280205d" providerId="ADAL" clId="{CE03E1C6-2D51-4ED0-B122-F20503508803}" dt="2025-12-16T10:52:53.301" v="438" actId="478"/>
-          <ac:spMkLst>
-            <pc:docMk/>
-            <pc:sldMk cId="2622637710" sldId="260"/>
-            <ac:spMk id="13" creationId="{ADF2B792-481D-2C7E-DCDC-4616A4AE7E0D}"/>
-          </ac:spMkLst>
-        </pc:spChg>
-        <pc:spChg chg="mod">
-          <ac:chgData name="Sandra Klemet-N'guessan" userId="0d19dd2d-6e00-409e-9933-e191f280205d" providerId="ADAL" clId="{CE03E1C6-2D51-4ED0-B122-F20503508803}" dt="2025-12-16T14:43:07.932" v="602" actId="1076"/>
-          <ac:spMkLst>
-            <pc:docMk/>
-            <pc:sldMk cId="2622637710" sldId="260"/>
-            <ac:spMk id="15" creationId="{0381E21F-53D1-10BD-D2B8-3BE68D95D66B}"/>
-          </ac:spMkLst>
-        </pc:spChg>
-        <pc:spChg chg="mod">
-          <ac:chgData name="Sandra Klemet-N'guessan" userId="0d19dd2d-6e00-409e-9933-e191f280205d" providerId="ADAL" clId="{CE03E1C6-2D51-4ED0-B122-F20503508803}" dt="2025-12-16T14:43:07.932" v="602" actId="1076"/>
-          <ac:spMkLst>
-            <pc:docMk/>
-            <pc:sldMk cId="2622637710" sldId="260"/>
-            <ac:spMk id="17" creationId="{2FB81E07-14E9-20B4-154B-F46295F630BB}"/>
-          </ac:spMkLst>
-        </pc:spChg>
-        <pc:spChg chg="mod">
-          <ac:chgData name="Sandra Klemet-N'guessan" userId="0d19dd2d-6e00-409e-9933-e191f280205d" providerId="ADAL" clId="{CE03E1C6-2D51-4ED0-B122-F20503508803}" dt="2025-12-16T14:43:42.494" v="609" actId="1076"/>
-          <ac:spMkLst>
-            <pc:docMk/>
-            <pc:sldMk cId="2622637710" sldId="260"/>
-            <ac:spMk id="19" creationId="{3D65ABC0-C8ED-7ECA-20E0-A78395953AB8}"/>
-          </ac:spMkLst>
-        </pc:spChg>
-        <pc:spChg chg="mod">
-          <ac:chgData name="Sandra Klemet-N'guessan" userId="0d19dd2d-6e00-409e-9933-e191f280205d" providerId="ADAL" clId="{CE03E1C6-2D51-4ED0-B122-F20503508803}" dt="2025-12-16T11:45:36.854" v="518" actId="1076"/>
-          <ac:spMkLst>
-            <pc:docMk/>
-            <pc:sldMk cId="2622637710" sldId="260"/>
-            <ac:spMk id="20" creationId="{E711F827-4D5A-8BA1-A133-8D3A408BF615}"/>
-          </ac:spMkLst>
-        </pc:spChg>
-        <pc:spChg chg="mod">
-          <ac:chgData name="Sandra Klemet-N'guessan" userId="0d19dd2d-6e00-409e-9933-e191f280205d" providerId="ADAL" clId="{CE03E1C6-2D51-4ED0-B122-F20503508803}" dt="2025-12-16T14:45:34.926" v="629" actId="1076"/>
-          <ac:spMkLst>
-            <pc:docMk/>
-            <pc:sldMk cId="2622637710" sldId="260"/>
-            <ac:spMk id="28" creationId="{17167F32-47E6-B94B-B203-ABC36FF648EB}"/>
-          </ac:spMkLst>
-        </pc:spChg>
-        <pc:spChg chg="mod">
-          <ac:chgData name="Sandra Klemet-N'guessan" userId="0d19dd2d-6e00-409e-9933-e191f280205d" providerId="ADAL" clId="{CE03E1C6-2D51-4ED0-B122-F20503508803}" dt="2025-12-16T13:59:05.873" v="581" actId="20577"/>
+          <ac:chgData name="Sandra Klemet-N'guessan" userId="0d19dd2d-6e00-409e-9933-e191f280205d" providerId="ADAL" clId="{89BD5EB5-483A-4D23-98EB-6C08039E7710}" dt="2026-03-14T23:47:49.112" v="15" actId="1076"/>
           <ac:spMkLst>
             <pc:docMk/>
             <pc:sldMk cId="2622637710" sldId="260"/>
             <ac:spMk id="37" creationId="{BE38B3E5-43E2-1E93-B954-B7D5AC762FDA}"/>
           </ac:spMkLst>
         </pc:spChg>
-        <pc:spChg chg="mod">
-          <ac:chgData name="Sandra Klemet-N'guessan" userId="0d19dd2d-6e00-409e-9933-e191f280205d" providerId="ADAL" clId="{CE03E1C6-2D51-4ED0-B122-F20503508803}" dt="2025-12-16T14:45:29.362" v="628" actId="1076"/>
-          <ac:spMkLst>
-            <pc:docMk/>
-            <pc:sldMk cId="2622637710" sldId="260"/>
-            <ac:spMk id="42" creationId="{723AAFD8-00BE-0450-3E1A-B7445101743E}"/>
-          </ac:spMkLst>
-        </pc:spChg>
-        <pc:spChg chg="mod">
-          <ac:chgData name="Sandra Klemet-N'guessan" userId="0d19dd2d-6e00-409e-9933-e191f280205d" providerId="ADAL" clId="{CE03E1C6-2D51-4ED0-B122-F20503508803}" dt="2025-12-16T11:42:31.531" v="506" actId="1076"/>
-          <ac:spMkLst>
-            <pc:docMk/>
-            <pc:sldMk cId="2622637710" sldId="260"/>
-            <ac:spMk id="52" creationId="{A6237B62-7BD1-DB05-6A43-5FF7499E1E30}"/>
-          </ac:spMkLst>
-        </pc:spChg>
-        <pc:spChg chg="mod">
-          <ac:chgData name="Sandra Klemet-N'guessan" userId="0d19dd2d-6e00-409e-9933-e191f280205d" providerId="ADAL" clId="{CE03E1C6-2D51-4ED0-B122-F20503508803}" dt="2025-12-16T10:58:56.232" v="463" actId="14100"/>
-          <ac:spMkLst>
-            <pc:docMk/>
-            <pc:sldMk cId="2622637710" sldId="260"/>
-            <ac:spMk id="57" creationId="{3886C323-F51F-9103-E106-C49D36702E3A}"/>
-          </ac:spMkLst>
-        </pc:spChg>
-        <pc:spChg chg="mod">
-          <ac:chgData name="Sandra Klemet-N'guessan" userId="0d19dd2d-6e00-409e-9933-e191f280205d" providerId="ADAL" clId="{CE03E1C6-2D51-4ED0-B122-F20503508803}" dt="2025-12-16T14:44:14.896" v="617" actId="1076"/>
-          <ac:spMkLst>
-            <pc:docMk/>
-            <pc:sldMk cId="2622637710" sldId="260"/>
-            <ac:spMk id="58" creationId="{779B0E9A-27F7-606F-7D64-6115756828BD}"/>
-          </ac:spMkLst>
-        </pc:spChg>
-        <pc:spChg chg="mod">
-          <ac:chgData name="Sandra Klemet-N'guessan" userId="0d19dd2d-6e00-409e-9933-e191f280205d" providerId="ADAL" clId="{CE03E1C6-2D51-4ED0-B122-F20503508803}" dt="2025-12-16T14:44:12.312" v="616" actId="1076"/>
-          <ac:spMkLst>
-            <pc:docMk/>
-            <pc:sldMk cId="2622637710" sldId="260"/>
-            <ac:spMk id="59" creationId="{D18D22CD-FC91-D836-38C7-FD8D7CDE13E6}"/>
-          </ac:spMkLst>
-        </pc:spChg>
-        <pc:spChg chg="mod">
-          <ac:chgData name="Sandra Klemet-N'guessan" userId="0d19dd2d-6e00-409e-9933-e191f280205d" providerId="ADAL" clId="{CE03E1C6-2D51-4ED0-B122-F20503508803}" dt="2025-12-16T14:41:58.269" v="591" actId="1076"/>
-          <ac:spMkLst>
-            <pc:docMk/>
-            <pc:sldMk cId="2622637710" sldId="260"/>
-            <ac:spMk id="72" creationId="{B03A24B0-2875-9804-50EB-5FCC702FF57D}"/>
-          </ac:spMkLst>
-        </pc:spChg>
-        <pc:spChg chg="mod">
-          <ac:chgData name="Sandra Klemet-N'guessan" userId="0d19dd2d-6e00-409e-9933-e191f280205d" providerId="ADAL" clId="{CE03E1C6-2D51-4ED0-B122-F20503508803}" dt="2025-12-16T14:43:07.932" v="602" actId="1076"/>
-          <ac:spMkLst>
-            <pc:docMk/>
-            <pc:sldMk cId="2622637710" sldId="260"/>
-            <ac:spMk id="99" creationId="{F7D9C9AC-A548-0B6B-E12C-9B9FA5D924C0}"/>
-          </ac:spMkLst>
-        </pc:spChg>
-        <pc:picChg chg="add del mod">
-          <ac:chgData name="Sandra Klemet-N'guessan" userId="0d19dd2d-6e00-409e-9933-e191f280205d" providerId="ADAL" clId="{CE03E1C6-2D51-4ED0-B122-F20503508803}" dt="2025-12-16T14:43:07.932" v="602" actId="1076"/>
-          <ac:picMkLst>
-            <pc:docMk/>
-            <pc:sldMk cId="2622637710" sldId="260"/>
-            <ac:picMk id="6" creationId="{955C1C61-7C36-4A66-F8E0-64B5826339AA}"/>
-          </ac:picMkLst>
-        </pc:picChg>
-        <pc:picChg chg="add del mod">
-          <ac:chgData name="Sandra Klemet-N'guessan" userId="0d19dd2d-6e00-409e-9933-e191f280205d" providerId="ADAL" clId="{CE03E1C6-2D51-4ED0-B122-F20503508803}" dt="2025-12-16T10:58:22.722" v="457" actId="478"/>
-          <ac:picMkLst>
-            <pc:docMk/>
-            <pc:sldMk cId="2622637710" sldId="260"/>
-            <ac:picMk id="7" creationId="{AC83CE6B-0EFE-5C5C-8FDB-C8FE8121A951}"/>
-          </ac:picMkLst>
-        </pc:picChg>
-        <pc:picChg chg="add del mod">
-          <ac:chgData name="Sandra Klemet-N'guessan" userId="0d19dd2d-6e00-409e-9933-e191f280205d" providerId="ADAL" clId="{CE03E1C6-2D51-4ED0-B122-F20503508803}" dt="2025-12-16T10:55:07.364" v="453" actId="478"/>
-          <ac:picMkLst>
-            <pc:docMk/>
-            <pc:sldMk cId="2622637710" sldId="260"/>
-            <ac:picMk id="9" creationId="{079E5150-3AAE-25FB-F1FD-AFA54CB449A7}"/>
-          </ac:picMkLst>
-        </pc:picChg>
-        <pc:picChg chg="add del mod">
-          <ac:chgData name="Sandra Klemet-N'guessan" userId="0d19dd2d-6e00-409e-9933-e191f280205d" providerId="ADAL" clId="{CE03E1C6-2D51-4ED0-B122-F20503508803}" dt="2025-12-16T11:49:44.602" v="539" actId="478"/>
-          <ac:picMkLst>
-            <pc:docMk/>
-            <pc:sldMk cId="2622637710" sldId="260"/>
-            <ac:picMk id="18" creationId="{DB060DAC-1B59-F704-962E-22F093CB0850}"/>
-          </ac:picMkLst>
-        </pc:picChg>
-        <pc:picChg chg="add del mod">
-          <ac:chgData name="Sandra Klemet-N'guessan" userId="0d19dd2d-6e00-409e-9933-e191f280205d" providerId="ADAL" clId="{CE03E1C6-2D51-4ED0-B122-F20503508803}" dt="2025-12-16T11:49:42.292" v="538" actId="478"/>
-          <ac:picMkLst>
-            <pc:docMk/>
-            <pc:sldMk cId="2622637710" sldId="260"/>
-            <ac:picMk id="2050" creationId="{7E6EFFF4-F672-3CF3-844D-5BD3BE4D50E6}"/>
-          </ac:picMkLst>
-        </pc:picChg>
-        <pc:picChg chg="add mod">
-          <ac:chgData name="Sandra Klemet-N'guessan" userId="0d19dd2d-6e00-409e-9933-e191f280205d" providerId="ADAL" clId="{CE03E1C6-2D51-4ED0-B122-F20503508803}" dt="2025-12-16T11:04:10.389" v="476" actId="14100"/>
-          <ac:picMkLst>
-            <pc:docMk/>
-            <pc:sldMk cId="2622637710" sldId="260"/>
-            <ac:picMk id="2052" creationId="{6EF1D489-78AD-55AF-97C7-5EDE7BCDACF9}"/>
-          </ac:picMkLst>
-        </pc:picChg>
-        <pc:picChg chg="add del mod">
-          <ac:chgData name="Sandra Klemet-N'guessan" userId="0d19dd2d-6e00-409e-9933-e191f280205d" providerId="ADAL" clId="{CE03E1C6-2D51-4ED0-B122-F20503508803}" dt="2025-12-16T11:50:56.209" v="553" actId="478"/>
-          <ac:picMkLst>
-            <pc:docMk/>
-            <pc:sldMk cId="2622637710" sldId="260"/>
-            <ac:picMk id="2054" creationId="{B730CD07-E5A0-1355-984E-67CB94042B1B}"/>
-          </ac:picMkLst>
-        </pc:picChg>
-        <pc:picChg chg="add mod">
-          <ac:chgData name="Sandra Klemet-N'guessan" userId="0d19dd2d-6e00-409e-9933-e191f280205d" providerId="ADAL" clId="{CE03E1C6-2D51-4ED0-B122-F20503508803}" dt="2025-12-16T11:51:08.530" v="558" actId="1076"/>
-          <ac:picMkLst>
-            <pc:docMk/>
-            <pc:sldMk cId="2622637710" sldId="260"/>
-            <ac:picMk id="2056" creationId="{B424337B-4D80-9B16-AE32-627D9AD86C5F}"/>
-          </ac:picMkLst>
-        </pc:picChg>
-        <pc:cxnChg chg="mod">
-          <ac:chgData name="Sandra Klemet-N'guessan" userId="0d19dd2d-6e00-409e-9933-e191f280205d" providerId="ADAL" clId="{CE03E1C6-2D51-4ED0-B122-F20503508803}" dt="2025-12-16T13:59:15.577" v="583" actId="14100"/>
+        <pc:cxnChg chg="add mod ord">
+          <ac:chgData name="Sandra Klemet-N'guessan" userId="0d19dd2d-6e00-409e-9933-e191f280205d" providerId="ADAL" clId="{89BD5EB5-483A-4D23-98EB-6C08039E7710}" dt="2026-03-14T23:49:05.140" v="27" actId="167"/>
           <ac:cxnSpMkLst>
             <pc:docMk/>
             <pc:sldMk cId="2622637710" sldId="260"/>
-            <ac:cxnSpMk id="5" creationId="{1F1CE52C-9D32-9A09-E063-C79AC794A08C}"/>
-          </ac:cxnSpMkLst>
-        </pc:cxnChg>
-        <pc:cxnChg chg="mod">
-          <ac:chgData name="Sandra Klemet-N'guessan" userId="0d19dd2d-6e00-409e-9933-e191f280205d" providerId="ADAL" clId="{CE03E1C6-2D51-4ED0-B122-F20503508803}" dt="2025-12-16T14:44:45.413" v="622" actId="1076"/>
-          <ac:cxnSpMkLst>
-            <pc:docMk/>
-            <pc:sldMk cId="2622637710" sldId="260"/>
-            <ac:cxnSpMk id="8" creationId="{5E483ACC-3D60-C12B-6EF3-40041E64CB44}"/>
-          </ac:cxnSpMkLst>
-        </pc:cxnChg>
-        <pc:cxnChg chg="mod">
-          <ac:chgData name="Sandra Klemet-N'guessan" userId="0d19dd2d-6e00-409e-9933-e191f280205d" providerId="ADAL" clId="{CE03E1C6-2D51-4ED0-B122-F20503508803}" dt="2025-12-16T14:44:54.540" v="623" actId="1076"/>
-          <ac:cxnSpMkLst>
-            <pc:docMk/>
-            <pc:sldMk cId="2622637710" sldId="260"/>
-            <ac:cxnSpMk id="14" creationId="{FCA09A86-1F1D-AA79-3740-E54DCFD4C5CC}"/>
-          </ac:cxnSpMkLst>
-        </pc:cxnChg>
-        <pc:cxnChg chg="mod">
-          <ac:chgData name="Sandra Klemet-N'guessan" userId="0d19dd2d-6e00-409e-9933-e191f280205d" providerId="ADAL" clId="{CE03E1C6-2D51-4ED0-B122-F20503508803}" dt="2025-12-16T14:45:16.962" v="626" actId="1076"/>
-          <ac:cxnSpMkLst>
-            <pc:docMk/>
-            <pc:sldMk cId="2622637710" sldId="260"/>
-            <ac:cxnSpMk id="27" creationId="{DEBC4BB2-7BA5-AE19-1C0E-FC4D3D446D34}"/>
-          </ac:cxnSpMkLst>
-        </pc:cxnChg>
-        <pc:cxnChg chg="mod">
-          <ac:chgData name="Sandra Klemet-N'guessan" userId="0d19dd2d-6e00-409e-9933-e191f280205d" providerId="ADAL" clId="{CE03E1C6-2D51-4ED0-B122-F20503508803}" dt="2025-12-16T11:36:20.161" v="486" actId="14100"/>
-          <ac:cxnSpMkLst>
-            <pc:docMk/>
-            <pc:sldMk cId="2622637710" sldId="260"/>
-            <ac:cxnSpMk id="33" creationId="{C9005185-9AB4-7B78-9B46-B71050A91773}"/>
-          </ac:cxnSpMkLst>
-        </pc:cxnChg>
-        <pc:cxnChg chg="mod">
-          <ac:chgData name="Sandra Klemet-N'guessan" userId="0d19dd2d-6e00-409e-9933-e191f280205d" providerId="ADAL" clId="{CE03E1C6-2D51-4ED0-B122-F20503508803}" dt="2025-12-16T14:44:21.234" v="619" actId="14100"/>
-          <ac:cxnSpMkLst>
-            <pc:docMk/>
-            <pc:sldMk cId="2622637710" sldId="260"/>
-            <ac:cxnSpMk id="38" creationId="{28BDF8BA-48BA-6762-2FD8-DC0C38436866}"/>
-          </ac:cxnSpMkLst>
-        </pc:cxnChg>
-        <pc:cxnChg chg="mod">
-          <ac:chgData name="Sandra Klemet-N'guessan" userId="0d19dd2d-6e00-409e-9933-e191f280205d" providerId="ADAL" clId="{CE03E1C6-2D51-4ED0-B122-F20503508803}" dt="2025-12-16T14:45:19.613" v="627" actId="1076"/>
-          <ac:cxnSpMkLst>
-            <pc:docMk/>
-            <pc:sldMk cId="2622637710" sldId="260"/>
-            <ac:cxnSpMk id="41" creationId="{AF2C2E4A-2E30-3A31-236F-E552111AB165}"/>
-          </ac:cxnSpMkLst>
-        </pc:cxnChg>
-        <pc:cxnChg chg="mod">
-          <ac:chgData name="Sandra Klemet-N'guessan" userId="0d19dd2d-6e00-409e-9933-e191f280205d" providerId="ADAL" clId="{CE03E1C6-2D51-4ED0-B122-F20503508803}" dt="2025-12-16T11:54:56.485" v="568" actId="14100"/>
-          <ac:cxnSpMkLst>
-            <pc:docMk/>
-            <pc:sldMk cId="2622637710" sldId="260"/>
-            <ac:cxnSpMk id="46" creationId="{DA0AF886-62C3-17A9-36C0-CEA79115EFE4}"/>
-          </ac:cxnSpMkLst>
-        </pc:cxnChg>
-        <pc:cxnChg chg="mod">
-          <ac:chgData name="Sandra Klemet-N'guessan" userId="0d19dd2d-6e00-409e-9933-e191f280205d" providerId="ADAL" clId="{CE03E1C6-2D51-4ED0-B122-F20503508803}" dt="2025-12-16T14:44:33.012" v="621" actId="1076"/>
-          <ac:cxnSpMkLst>
-            <pc:docMk/>
-            <pc:sldMk cId="2622637710" sldId="260"/>
-            <ac:cxnSpMk id="48" creationId="{FA904A84-1B72-ECE2-9D5D-9D0C69F978EA}"/>
+            <ac:cxnSpMk id="7" creationId="{2210BF14-97D1-AFE9-68FA-5EB04C8B1AEA}"/>
           </ac:cxnSpMkLst>
         </pc:cxnChg>
       </pc:sldChg>
@@ -1011,7 +414,7 @@
           <a:p>
             <a:fld id="{445DB300-8F4B-45C4-B9E9-804130C34BE9}" type="datetimeFigureOut">
               <a:rPr lang="en-CA" smtClean="0"/>
-              <a:t>2025-12-15</a:t>
+              <a:t>2026-03-14</a:t>
             </a:fld>
             <a:endParaRPr lang="en-CA"/>
           </a:p>
@@ -1919,7 +1322,7 @@
           <a:p>
             <a:fld id="{1F45F53F-C4AC-4A87-8144-5C7323FA25C7}" type="datetimeFigureOut">
               <a:rPr lang="en-CA" smtClean="0"/>
-              <a:t>2025-12-14</a:t>
+              <a:t>2026-03-14</a:t>
             </a:fld>
             <a:endParaRPr lang="en-CA"/>
           </a:p>
@@ -2119,7 +1522,7 @@
           <a:p>
             <a:fld id="{1F45F53F-C4AC-4A87-8144-5C7323FA25C7}" type="datetimeFigureOut">
               <a:rPr lang="en-CA" smtClean="0"/>
-              <a:t>2025-12-14</a:t>
+              <a:t>2026-03-14</a:t>
             </a:fld>
             <a:endParaRPr lang="en-CA"/>
           </a:p>
@@ -2329,7 +1732,7 @@
           <a:p>
             <a:fld id="{1F45F53F-C4AC-4A87-8144-5C7323FA25C7}" type="datetimeFigureOut">
               <a:rPr lang="en-CA" smtClean="0"/>
-              <a:t>2025-12-14</a:t>
+              <a:t>2026-03-14</a:t>
             </a:fld>
             <a:endParaRPr lang="en-CA"/>
           </a:p>
@@ -2529,7 +1932,7 @@
           <a:p>
             <a:fld id="{1F45F53F-C4AC-4A87-8144-5C7323FA25C7}" type="datetimeFigureOut">
               <a:rPr lang="en-CA" smtClean="0"/>
-              <a:t>2025-12-14</a:t>
+              <a:t>2026-03-14</a:t>
             </a:fld>
             <a:endParaRPr lang="en-CA"/>
           </a:p>
@@ -2805,7 +2208,7 @@
           <a:p>
             <a:fld id="{1F45F53F-C4AC-4A87-8144-5C7323FA25C7}" type="datetimeFigureOut">
               <a:rPr lang="en-CA" smtClean="0"/>
-              <a:t>2025-12-14</a:t>
+              <a:t>2026-03-14</a:t>
             </a:fld>
             <a:endParaRPr lang="en-CA"/>
           </a:p>
@@ -3073,7 +2476,7 @@
           <a:p>
             <a:fld id="{1F45F53F-C4AC-4A87-8144-5C7323FA25C7}" type="datetimeFigureOut">
               <a:rPr lang="en-CA" smtClean="0"/>
-              <a:t>2025-12-14</a:t>
+              <a:t>2026-03-14</a:t>
             </a:fld>
             <a:endParaRPr lang="en-CA"/>
           </a:p>
@@ -3488,7 +2891,7 @@
           <a:p>
             <a:fld id="{1F45F53F-C4AC-4A87-8144-5C7323FA25C7}" type="datetimeFigureOut">
               <a:rPr lang="en-CA" smtClean="0"/>
-              <a:t>2025-12-14</a:t>
+              <a:t>2026-03-14</a:t>
             </a:fld>
             <a:endParaRPr lang="en-CA"/>
           </a:p>
@@ -3630,7 +3033,7 @@
           <a:p>
             <a:fld id="{1F45F53F-C4AC-4A87-8144-5C7323FA25C7}" type="datetimeFigureOut">
               <a:rPr lang="en-CA" smtClean="0"/>
-              <a:t>2025-12-14</a:t>
+              <a:t>2026-03-14</a:t>
             </a:fld>
             <a:endParaRPr lang="en-CA"/>
           </a:p>
@@ -3743,7 +3146,7 @@
           <a:p>
             <a:fld id="{1F45F53F-C4AC-4A87-8144-5C7323FA25C7}" type="datetimeFigureOut">
               <a:rPr lang="en-CA" smtClean="0"/>
-              <a:t>2025-12-14</a:t>
+              <a:t>2026-03-14</a:t>
             </a:fld>
             <a:endParaRPr lang="en-CA"/>
           </a:p>
@@ -4056,7 +3459,7 @@
           <a:p>
             <a:fld id="{1F45F53F-C4AC-4A87-8144-5C7323FA25C7}" type="datetimeFigureOut">
               <a:rPr lang="en-CA" smtClean="0"/>
-              <a:t>2025-12-14</a:t>
+              <a:t>2026-03-14</a:t>
             </a:fld>
             <a:endParaRPr lang="en-CA"/>
           </a:p>
@@ -4345,7 +3748,7 @@
           <a:p>
             <a:fld id="{1F45F53F-C4AC-4A87-8144-5C7323FA25C7}" type="datetimeFigureOut">
               <a:rPr lang="en-CA" smtClean="0"/>
-              <a:t>2025-12-14</a:t>
+              <a:t>2026-03-14</a:t>
             </a:fld>
             <a:endParaRPr lang="en-CA"/>
           </a:p>
@@ -4588,7 +3991,7 @@
           <a:p>
             <a:fld id="{1F45F53F-C4AC-4A87-8144-5C7323FA25C7}" type="datetimeFigureOut">
               <a:rPr lang="en-CA" smtClean="0"/>
-              <a:t>2025-12-14</a:t>
+              <a:t>2026-03-14</a:t>
             </a:fld>
             <a:endParaRPr lang="en-CA"/>
           </a:p>
@@ -7356,6 +6759,51 @@
           <a:chExt cx="0" cy="0"/>
         </a:xfrm>
       </p:grpSpPr>
+      <p:cxnSp>
+        <p:nvCxnSpPr>
+          <p:cNvPr id="7" name="Straight Arrow Connector 6">
+            <a:extLst>
+              <a:ext uri="{FF2B5EF4-FFF2-40B4-BE49-F238E27FC236}">
+                <a16:creationId xmlns:a16="http://schemas.microsoft.com/office/drawing/2014/main" id="{2210BF14-97D1-AFE9-68FA-5EB04C8B1AEA}"/>
+              </a:ext>
+            </a:extLst>
+          </p:cNvPr>
+          <p:cNvCxnSpPr>
+            <a:cxnSpLocks/>
+          </p:cNvCxnSpPr>
+          <p:nvPr/>
+        </p:nvCxnSpPr>
+        <p:spPr>
+          <a:xfrm>
+            <a:off x="7857784" y="3545328"/>
+            <a:ext cx="3257507" cy="19062"/>
+          </a:xfrm>
+          <a:prstGeom prst="straightConnector1">
+            <a:avLst/>
+          </a:prstGeom>
+          <a:ln w="50800">
+            <a:solidFill>
+              <a:schemeClr val="tx1"/>
+            </a:solidFill>
+            <a:headEnd type="none" w="med" len="med"/>
+            <a:tailEnd type="none" w="med" len="med"/>
+          </a:ln>
+        </p:spPr>
+        <p:style>
+          <a:lnRef idx="2">
+            <a:schemeClr val="dk1"/>
+          </a:lnRef>
+          <a:fillRef idx="0">
+            <a:schemeClr val="dk1"/>
+          </a:fillRef>
+          <a:effectRef idx="1">
+            <a:schemeClr val="dk1"/>
+          </a:effectRef>
+          <a:fontRef idx="minor">
+            <a:schemeClr val="tx1"/>
+          </a:fontRef>
+        </p:style>
+      </p:cxnSp>
       <p:sp>
         <p:nvSpPr>
           <p:cNvPr id="2" name="Rectangle 1">
@@ -8060,7 +7508,7 @@
         </p:nvSpPr>
         <p:spPr>
           <a:xfrm>
-            <a:off x="8773526" y="3489972"/>
+            <a:off x="8575279" y="4104871"/>
             <a:ext cx="1294639" cy="369332"/>
           </a:xfrm>
           <a:prstGeom prst="rect">
@@ -8703,6 +8151,41 @@
           </a:extLst>
         </p:spPr>
       </p:pic>
+      <p:sp>
+        <p:nvSpPr>
+          <p:cNvPr id="13" name="TextBox 12">
+            <a:extLst>
+              <a:ext uri="{FF2B5EF4-FFF2-40B4-BE49-F238E27FC236}">
+                <a16:creationId xmlns:a16="http://schemas.microsoft.com/office/drawing/2014/main" id="{EC325244-F071-15DE-8442-D93324BA0D3C}"/>
+              </a:ext>
+            </a:extLst>
+          </p:cNvPr>
+          <p:cNvSpPr txBox="1"/>
+          <p:nvPr/>
+        </p:nvSpPr>
+        <p:spPr>
+          <a:xfrm>
+            <a:off x="8703806" y="3155886"/>
+            <a:ext cx="1530743" cy="369332"/>
+          </a:xfrm>
+          <a:prstGeom prst="rect">
+            <a:avLst/>
+          </a:prstGeom>
+          <a:noFill/>
+        </p:spPr>
+        <p:txBody>
+          <a:bodyPr wrap="square" rtlCol="0">
+            <a:spAutoFit/>
+          </a:bodyPr>
+          <a:lstStyle/>
+          <a:p>
+            <a:r>
+              <a:rPr lang="en-CA" dirty="0"/>
+              <a:t>Outflow</a:t>
+            </a:r>
+          </a:p>
+        </p:txBody>
+      </p:sp>
     </p:spTree>
     <p:extLst>
       <p:ext uri="{BB962C8B-B14F-4D97-AF65-F5344CB8AC3E}">

</xml_diff>